<commit_message>
Updated font to Arial in app.R and template.pptx
</commit_message>
<xml_diff>
--- a/template.pptx
+++ b/template.pptx
@@ -117,20 +117,20 @@
 <file path=ppt/changesInfos/changesInfo1.xml><?xml version="1.0" encoding="utf-8"?>
 <pc:chgInfo xmlns:a="http://schemas.openxmlformats.org/drawingml/2006/main" xmlns:r="http://schemas.openxmlformats.org/officeDocument/2006/relationships" xmlns:ac="http://schemas.microsoft.com/office/drawing/2013/main/command" xmlns:pc="http://schemas.microsoft.com/office/powerpoint/2013/main/command">
   <pc:docChgLst>
-    <pc:chgData name="Devin Heanue" userId="7590fe87-f85b-4db3-af49-40606f5bf96f" providerId="ADAL" clId="{0AE716D6-5FAA-4FA4-BA3F-12263BBDF976}"/>
-    <pc:docChg chg="undo custSel addSld delSld modSld modMainMaster">
-      <pc:chgData name="Devin Heanue" userId="7590fe87-f85b-4db3-af49-40606f5bf96f" providerId="ADAL" clId="{0AE716D6-5FAA-4FA4-BA3F-12263BBDF976}" dt="2026-03-26T14:54:47.439" v="86" actId="1076"/>
+    <pc:chgData name="Devin Heanue" userId="7590fe87-f85b-4db3-af49-40606f5bf96f" providerId="ADAL" clId="{A2D90BA2-02A7-4AB1-8229-4C08CFF0E969}"/>
+    <pc:docChg chg="undo custSel modSld modMainMaster">
+      <pc:chgData name="Devin Heanue" userId="7590fe87-f85b-4db3-af49-40606f5bf96f" providerId="ADAL" clId="{A2D90BA2-02A7-4AB1-8229-4C08CFF0E969}" dt="2026-06-15T20:57:51.406" v="49" actId="14100"/>
       <pc:docMkLst>
         <pc:docMk/>
       </pc:docMkLst>
       <pc:sldChg chg="modSp mod">
-        <pc:chgData name="Devin Heanue" userId="7590fe87-f85b-4db3-af49-40606f5bf96f" providerId="ADAL" clId="{0AE716D6-5FAA-4FA4-BA3F-12263BBDF976}" dt="2026-03-19T15:26:10.314" v="9" actId="207"/>
+        <pc:chgData name="Devin Heanue" userId="7590fe87-f85b-4db3-af49-40606f5bf96f" providerId="ADAL" clId="{A2D90BA2-02A7-4AB1-8229-4C08CFF0E969}" dt="2026-06-15T20:57:51.406" v="49" actId="14100"/>
         <pc:sldMkLst>
           <pc:docMk/>
           <pc:sldMk cId="327460940" sldId="257"/>
         </pc:sldMkLst>
         <pc:spChg chg="mod">
-          <ac:chgData name="Devin Heanue" userId="7590fe87-f85b-4db3-af49-40606f5bf96f" providerId="ADAL" clId="{0AE716D6-5FAA-4FA4-BA3F-12263BBDF976}" dt="2026-03-19T15:26:10.314" v="9" actId="207"/>
+          <ac:chgData name="Devin Heanue" userId="7590fe87-f85b-4db3-af49-40606f5bf96f" providerId="ADAL" clId="{A2D90BA2-02A7-4AB1-8229-4C08CFF0E969}" dt="2026-06-15T20:57:51.406" v="49" actId="14100"/>
           <ac:spMkLst>
             <pc:docMk/>
             <pc:sldMk cId="327460940" sldId="257"/>
@@ -138,93 +138,21 @@
           </ac:spMkLst>
         </pc:spChg>
       </pc:sldChg>
-      <pc:sldChg chg="modSp">
-        <pc:chgData name="Devin Heanue" userId="7590fe87-f85b-4db3-af49-40606f5bf96f" providerId="ADAL" clId="{0AE716D6-5FAA-4FA4-BA3F-12263BBDF976}" dt="2026-03-19T13:58:48.720" v="1"/>
-        <pc:sldMkLst>
-          <pc:docMk/>
-          <pc:sldMk cId="3275027838" sldId="350"/>
-        </pc:sldMkLst>
-        <pc:spChg chg="mod">
-          <ac:chgData name="Devin Heanue" userId="7590fe87-f85b-4db3-af49-40606f5bf96f" providerId="ADAL" clId="{0AE716D6-5FAA-4FA4-BA3F-12263BBDF976}" dt="2026-03-19T13:58:48.720" v="1"/>
-          <ac:spMkLst>
-            <pc:docMk/>
-            <pc:sldMk cId="3275027838" sldId="350"/>
-            <ac:spMk id="3" creationId="{5AC44777-8983-4366-4BC2-D62330047D28}"/>
-          </ac:spMkLst>
-        </pc:spChg>
-        <pc:picChg chg="mod">
-          <ac:chgData name="Devin Heanue" userId="7590fe87-f85b-4db3-af49-40606f5bf96f" providerId="ADAL" clId="{0AE716D6-5FAA-4FA4-BA3F-12263BBDF976}" dt="2026-03-19T13:58:48.720" v="1"/>
-          <ac:picMkLst>
-            <pc:docMk/>
-            <pc:sldMk cId="3275027838" sldId="350"/>
-            <ac:picMk id="7" creationId="{4DB909B4-2FA7-D63C-BE73-8D3C3EDF99F8}"/>
-          </ac:picMkLst>
-        </pc:picChg>
-      </pc:sldChg>
       <pc:sldMasterChg chg="modSldLayout">
-        <pc:chgData name="Devin Heanue" userId="7590fe87-f85b-4db3-af49-40606f5bf96f" providerId="ADAL" clId="{0AE716D6-5FAA-4FA4-BA3F-12263BBDF976}" dt="2026-03-19T13:58:30.797" v="0" actId="16037"/>
-        <pc:sldMasterMkLst>
-          <pc:docMk/>
-          <pc:sldMasterMk cId="1628519446" sldId="2147483662"/>
-        </pc:sldMasterMkLst>
-        <pc:sldLayoutChg chg="modSp">
-          <pc:chgData name="Devin Heanue" userId="7590fe87-f85b-4db3-af49-40606f5bf96f" providerId="ADAL" clId="{0AE716D6-5FAA-4FA4-BA3F-12263BBDF976}" dt="2026-03-19T13:58:30.797" v="0" actId="16037"/>
-          <pc:sldLayoutMkLst>
-            <pc:docMk/>
-            <pc:sldMasterMk cId="1628519446" sldId="2147483662"/>
-            <pc:sldLayoutMk cId="2057324489" sldId="2147483668"/>
-          </pc:sldLayoutMkLst>
-          <pc:spChg chg="mod">
-            <ac:chgData name="Devin Heanue" userId="7590fe87-f85b-4db3-af49-40606f5bf96f" providerId="ADAL" clId="{0AE716D6-5FAA-4FA4-BA3F-12263BBDF976}" dt="2026-03-19T13:58:30.797" v="0" actId="16037"/>
-            <ac:spMkLst>
-              <pc:docMk/>
-              <pc:sldMasterMk cId="1628519446" sldId="2147483662"/>
-              <pc:sldLayoutMk cId="2057324489" sldId="2147483668"/>
-              <ac:spMk id="26" creationId="{ADD87412-82D6-A515-DF8B-025EDE80E7BF}"/>
-            </ac:spMkLst>
-          </pc:spChg>
-        </pc:sldLayoutChg>
-      </pc:sldMasterChg>
-      <pc:sldMasterChg chg="addSp modSldLayout sldLayoutOrd">
-        <pc:chgData name="Devin Heanue" userId="7590fe87-f85b-4db3-af49-40606f5bf96f" providerId="ADAL" clId="{0AE716D6-5FAA-4FA4-BA3F-12263BBDF976}" dt="2026-03-26T14:54:47.439" v="86" actId="1076"/>
+        <pc:chgData name="Devin Heanue" userId="7590fe87-f85b-4db3-af49-40606f5bf96f" providerId="ADAL" clId="{A2D90BA2-02A7-4AB1-8229-4C08CFF0E969}" dt="2026-06-15T20:54:47.839" v="47" actId="1038"/>
         <pc:sldMasterMkLst>
           <pc:docMk/>
           <pc:sldMasterMk cId="2908370257" sldId="2147483669"/>
         </pc:sldMasterMkLst>
-        <pc:spChg chg="add">
-          <ac:chgData name="Devin Heanue" userId="7590fe87-f85b-4db3-af49-40606f5bf96f" providerId="ADAL" clId="{0AE716D6-5FAA-4FA4-BA3F-12263BBDF976}" dt="2026-03-19T13:58:48.720" v="1"/>
-          <ac:spMkLst>
-            <pc:docMk/>
-            <pc:sldMasterMk cId="2908370257" sldId="2147483669"/>
-            <ac:spMk id="7" creationId="{4DB2B117-B05E-B3D6-71CB-835C5A728637}"/>
-          </ac:spMkLst>
-        </pc:spChg>
-        <pc:sldLayoutChg chg="delSp modSp mod ord">
-          <pc:chgData name="Devin Heanue" userId="7590fe87-f85b-4db3-af49-40606f5bf96f" providerId="ADAL" clId="{0AE716D6-5FAA-4FA4-BA3F-12263BBDF976}" dt="2026-03-19T15:55:16.510" v="26" actId="14100"/>
-          <pc:sldLayoutMkLst>
-            <pc:docMk/>
-            <pc:sldMasterMk cId="2908370257" sldId="2147483669"/>
-            <pc:sldLayoutMk cId="176462580" sldId="2147483671"/>
-          </pc:sldLayoutMkLst>
-          <pc:spChg chg="mod">
-            <ac:chgData name="Devin Heanue" userId="7590fe87-f85b-4db3-af49-40606f5bf96f" providerId="ADAL" clId="{0AE716D6-5FAA-4FA4-BA3F-12263BBDF976}" dt="2026-03-19T15:55:16.510" v="26" actId="14100"/>
-            <ac:spMkLst>
-              <pc:docMk/>
-              <pc:sldMasterMk cId="2908370257" sldId="2147483669"/>
-              <pc:sldLayoutMk cId="176462580" sldId="2147483671"/>
-              <ac:spMk id="3" creationId="{161CCDB9-B20B-B812-9DCA-0122035D8EEE}"/>
-            </ac:spMkLst>
-          </pc:spChg>
-        </pc:sldLayoutChg>
-        <pc:sldLayoutChg chg="modSp mod ord">
-          <pc:chgData name="Devin Heanue" userId="7590fe87-f85b-4db3-af49-40606f5bf96f" providerId="ADAL" clId="{0AE716D6-5FAA-4FA4-BA3F-12263BBDF976}" dt="2026-03-19T15:49:12.740" v="19" actId="12"/>
+        <pc:sldLayoutChg chg="addSp delSp modSp mod">
+          <pc:chgData name="Devin Heanue" userId="7590fe87-f85b-4db3-af49-40606f5bf96f" providerId="ADAL" clId="{A2D90BA2-02A7-4AB1-8229-4C08CFF0E969}" dt="2026-06-15T20:54:47.839" v="47" actId="1038"/>
           <pc:sldLayoutMkLst>
             <pc:docMk/>
             <pc:sldMasterMk cId="2908370257" sldId="2147483669"/>
             <pc:sldLayoutMk cId="652845060" sldId="2147483681"/>
           </pc:sldLayoutMkLst>
           <pc:spChg chg="mod">
-            <ac:chgData name="Devin Heanue" userId="7590fe87-f85b-4db3-af49-40606f5bf96f" providerId="ADAL" clId="{0AE716D6-5FAA-4FA4-BA3F-12263BBDF976}" dt="2026-03-19T15:41:37.800" v="10" actId="12"/>
+            <ac:chgData name="Devin Heanue" userId="7590fe87-f85b-4db3-af49-40606f5bf96f" providerId="ADAL" clId="{A2D90BA2-02A7-4AB1-8229-4C08CFF0E969}" dt="2026-06-15T20:49:04.591" v="18" actId="2711"/>
             <ac:spMkLst>
               <pc:docMk/>
               <pc:sldMasterMk cId="2908370257" sldId="2147483669"/>
@@ -233,7 +161,7 @@
             </ac:spMkLst>
           </pc:spChg>
           <pc:spChg chg="mod">
-            <ac:chgData name="Devin Heanue" userId="7590fe87-f85b-4db3-af49-40606f5bf96f" providerId="ADAL" clId="{0AE716D6-5FAA-4FA4-BA3F-12263BBDF976}" dt="2026-03-19T15:49:12.740" v="19" actId="12"/>
+            <ac:chgData name="Devin Heanue" userId="7590fe87-f85b-4db3-af49-40606f5bf96f" providerId="ADAL" clId="{A2D90BA2-02A7-4AB1-8229-4C08CFF0E969}" dt="2026-06-15T20:49:08.446" v="19" actId="2711"/>
             <ac:spMkLst>
               <pc:docMk/>
               <pc:sldMasterMk cId="2908370257" sldId="2147483669"/>
@@ -241,16 +169,43 @@
               <ac:spMk id="7" creationId="{6F5952BE-55A5-1C39-5E5E-035243667E75}"/>
             </ac:spMkLst>
           </pc:spChg>
+          <pc:spChg chg="mod">
+            <ac:chgData name="Devin Heanue" userId="7590fe87-f85b-4db3-af49-40606f5bf96f" providerId="ADAL" clId="{A2D90BA2-02A7-4AB1-8229-4C08CFF0E969}" dt="2026-06-15T20:48:58.139" v="17" actId="2711"/>
+            <ac:spMkLst>
+              <pc:docMk/>
+              <pc:sldMasterMk cId="2908370257" sldId="2147483669"/>
+              <pc:sldLayoutMk cId="652845060" sldId="2147483681"/>
+              <ac:spMk id="26" creationId="{ADD87412-82D6-A515-DF8B-025EDE80E7BF}"/>
+            </ac:spMkLst>
+          </pc:spChg>
+          <pc:picChg chg="del">
+            <ac:chgData name="Devin Heanue" userId="7590fe87-f85b-4db3-af49-40606f5bf96f" providerId="ADAL" clId="{A2D90BA2-02A7-4AB1-8229-4C08CFF0E969}" dt="2026-06-15T20:54:42.428" v="37" actId="478"/>
+            <ac:picMkLst>
+              <pc:docMk/>
+              <pc:sldMasterMk cId="2908370257" sldId="2147483669"/>
+              <pc:sldLayoutMk cId="652845060" sldId="2147483681"/>
+              <ac:picMk id="2" creationId="{B5422D96-EB6F-9EE4-2D78-3043BC60F2C3}"/>
+            </ac:picMkLst>
+          </pc:picChg>
+          <pc:picChg chg="add mod">
+            <ac:chgData name="Devin Heanue" userId="7590fe87-f85b-4db3-af49-40606f5bf96f" providerId="ADAL" clId="{A2D90BA2-02A7-4AB1-8229-4C08CFF0E969}" dt="2026-06-15T20:54:47.839" v="47" actId="1038"/>
+            <ac:picMkLst>
+              <pc:docMk/>
+              <pc:sldMasterMk cId="2908370257" sldId="2147483669"/>
+              <pc:sldLayoutMk cId="652845060" sldId="2147483681"/>
+              <ac:picMk id="4" creationId="{18081953-2D72-9015-BF3C-8DBEEC90855A}"/>
+            </ac:picMkLst>
+          </pc:picChg>
         </pc:sldLayoutChg>
-        <pc:sldLayoutChg chg="modSp mod ord">
-          <pc:chgData name="Devin Heanue" userId="7590fe87-f85b-4db3-af49-40606f5bf96f" providerId="ADAL" clId="{0AE716D6-5FAA-4FA4-BA3F-12263BBDF976}" dt="2026-03-26T14:54:47.439" v="86" actId="1076"/>
+        <pc:sldLayoutChg chg="modSp mod">
+          <pc:chgData name="Devin Heanue" userId="7590fe87-f85b-4db3-af49-40606f5bf96f" providerId="ADAL" clId="{A2D90BA2-02A7-4AB1-8229-4C08CFF0E969}" dt="2026-06-15T20:48:43.934" v="16" actId="1076"/>
           <pc:sldLayoutMkLst>
             <pc:docMk/>
             <pc:sldMasterMk cId="2908370257" sldId="2147483669"/>
             <pc:sldLayoutMk cId="2751855050" sldId="2147483682"/>
           </pc:sldLayoutMkLst>
           <pc:spChg chg="mod">
-            <ac:chgData name="Devin Heanue" userId="7590fe87-f85b-4db3-af49-40606f5bf96f" providerId="ADAL" clId="{0AE716D6-5FAA-4FA4-BA3F-12263BBDF976}" dt="2026-03-26T14:54:47.439" v="86" actId="1076"/>
+            <ac:chgData name="Devin Heanue" userId="7590fe87-f85b-4db3-af49-40606f5bf96f" providerId="ADAL" clId="{A2D90BA2-02A7-4AB1-8229-4C08CFF0E969}" dt="2026-06-15T20:47:03.176" v="3" actId="2711"/>
             <ac:spMkLst>
               <pc:docMk/>
               <pc:sldMasterMk cId="2908370257" sldId="2147483669"/>
@@ -259,7 +214,25 @@
             </ac:spMkLst>
           </pc:spChg>
           <pc:spChg chg="mod">
-            <ac:chgData name="Devin Heanue" userId="7590fe87-f85b-4db3-af49-40606f5bf96f" providerId="ADAL" clId="{0AE716D6-5FAA-4FA4-BA3F-12263BBDF976}" dt="2026-03-26T14:54:20.792" v="63" actId="1035"/>
+            <ac:chgData name="Devin Heanue" userId="7590fe87-f85b-4db3-af49-40606f5bf96f" providerId="ADAL" clId="{A2D90BA2-02A7-4AB1-8229-4C08CFF0E969}" dt="2026-06-15T20:47:18.320" v="6" actId="2711"/>
+            <ac:spMkLst>
+              <pc:docMk/>
+              <pc:sldMasterMk cId="2908370257" sldId="2147483669"/>
+              <pc:sldLayoutMk cId="2751855050" sldId="2147483682"/>
+              <ac:spMk id="4" creationId="{4192AA94-D130-27CA-2D26-05CB7CD00567}"/>
+            </ac:spMkLst>
+          </pc:spChg>
+          <pc:spChg chg="mod">
+            <ac:chgData name="Devin Heanue" userId="7590fe87-f85b-4db3-af49-40606f5bf96f" providerId="ADAL" clId="{A2D90BA2-02A7-4AB1-8229-4C08CFF0E969}" dt="2026-06-15T20:47:06.700" v="4" actId="2711"/>
+            <ac:spMkLst>
+              <pc:docMk/>
+              <pc:sldMasterMk cId="2908370257" sldId="2147483669"/>
+              <pc:sldLayoutMk cId="2751855050" sldId="2147483682"/>
+              <ac:spMk id="5" creationId="{57949E57-FFBE-8336-E4A5-52A4E35DE163}"/>
+            </ac:spMkLst>
+          </pc:spChg>
+          <pc:spChg chg="mod">
+            <ac:chgData name="Devin Heanue" userId="7590fe87-f85b-4db3-af49-40606f5bf96f" providerId="ADAL" clId="{A2D90BA2-02A7-4AB1-8229-4C08CFF0E969}" dt="2026-06-15T20:46:57.242" v="2" actId="2711"/>
             <ac:spMkLst>
               <pc:docMk/>
               <pc:sldMasterMk cId="2908370257" sldId="2147483669"/>
@@ -268,7 +241,25 @@
             </ac:spMkLst>
           </pc:spChg>
           <pc:spChg chg="mod">
-            <ac:chgData name="Devin Heanue" userId="7590fe87-f85b-4db3-af49-40606f5bf96f" providerId="ADAL" clId="{0AE716D6-5FAA-4FA4-BA3F-12263BBDF976}" dt="2026-03-19T15:58:18.529" v="30" actId="2711"/>
+            <ac:chgData name="Devin Heanue" userId="7590fe87-f85b-4db3-af49-40606f5bf96f" providerId="ADAL" clId="{A2D90BA2-02A7-4AB1-8229-4C08CFF0E969}" dt="2026-06-15T20:48:43.934" v="16" actId="1076"/>
+            <ac:spMkLst>
+              <pc:docMk/>
+              <pc:sldMasterMk cId="2908370257" sldId="2147483669"/>
+              <pc:sldLayoutMk cId="2751855050" sldId="2147483682"/>
+              <ac:spMk id="9" creationId="{7D3C532E-6B3B-C5A6-11AF-589BC84B7CC4}"/>
+            </ac:spMkLst>
+          </pc:spChg>
+          <pc:spChg chg="mod">
+            <ac:chgData name="Devin Heanue" userId="7590fe87-f85b-4db3-af49-40606f5bf96f" providerId="ADAL" clId="{A2D90BA2-02A7-4AB1-8229-4C08CFF0E969}" dt="2026-06-15T20:48:18.559" v="14" actId="1076"/>
+            <ac:spMkLst>
+              <pc:docMk/>
+              <pc:sldMasterMk cId="2908370257" sldId="2147483669"/>
+              <pc:sldLayoutMk cId="2751855050" sldId="2147483682"/>
+              <ac:spMk id="10" creationId="{41C25A80-F6EC-A0E7-7DC3-DC27B260E4B8}"/>
+            </ac:spMkLst>
+          </pc:spChg>
+          <pc:spChg chg="mod">
+            <ac:chgData name="Devin Heanue" userId="7590fe87-f85b-4db3-af49-40606f5bf96f" providerId="ADAL" clId="{A2D90BA2-02A7-4AB1-8229-4C08CFF0E969}" dt="2026-06-15T20:46:47.683" v="0" actId="2711"/>
             <ac:spMkLst>
               <pc:docMk/>
               <pc:sldMasterMk cId="2908370257" sldId="2147483669"/>
@@ -277,7 +268,16 @@
             </ac:spMkLst>
           </pc:spChg>
           <pc:spChg chg="mod">
-            <ac:chgData name="Devin Heanue" userId="7590fe87-f85b-4db3-af49-40606f5bf96f" providerId="ADAL" clId="{0AE716D6-5FAA-4FA4-BA3F-12263BBDF976}" dt="2026-03-23T14:00:38.745" v="36" actId="947"/>
+            <ac:chgData name="Devin Heanue" userId="7590fe87-f85b-4db3-af49-40606f5bf96f" providerId="ADAL" clId="{A2D90BA2-02A7-4AB1-8229-4C08CFF0E969}" dt="2026-06-15T20:47:13.163" v="5" actId="2711"/>
+            <ac:spMkLst>
+              <pc:docMk/>
+              <pc:sldMasterMk cId="2908370257" sldId="2147483669"/>
+              <pc:sldLayoutMk cId="2751855050" sldId="2147483682"/>
+              <ac:spMk id="12" creationId="{D692FE7A-E637-D8C3-9655-5D2DC4874DA1}"/>
+            </ac:spMkLst>
+          </pc:spChg>
+          <pc:spChg chg="mod">
+            <ac:chgData name="Devin Heanue" userId="7590fe87-f85b-4db3-af49-40606f5bf96f" providerId="ADAL" clId="{A2D90BA2-02A7-4AB1-8229-4C08CFF0E969}" dt="2026-06-15T20:46:51.808" v="1" actId="2711"/>
             <ac:spMkLst>
               <pc:docMk/>
               <pc:sldMasterMk cId="2908370257" sldId="2147483669"/>
@@ -680,7 +680,7 @@
           <a:p>
             <a:fld id="{35B24283-4C9C-384C-9A69-259DDC60D95C}" type="datetimeFigureOut">
               <a:rPr lang="en-US" smtClean="0"/>
-              <a:t>3/26/2026</a:t>
+              <a:t>6/15/2026</a:t>
             </a:fld>
             <a:endParaRPr lang="en-US"/>
           </a:p>
@@ -888,7 +888,7 @@
           <a:p>
             <a:fld id="{35B24283-4C9C-384C-9A69-259DDC60D95C}" type="datetimeFigureOut">
               <a:rPr lang="en-US" smtClean="0"/>
-              <a:t>3/26/2026</a:t>
+              <a:t>6/15/2026</a:t>
             </a:fld>
             <a:endParaRPr lang="en-US"/>
           </a:p>
@@ -1095,7 +1095,10 @@
           </a:bodyPr>
           <a:lstStyle>
             <a:lvl1pPr>
-              <a:defRPr sz="4400"/>
+              <a:defRPr sz="4400">
+                <a:latin typeface="Arial" panose="020B0604020202020204" pitchFamily="34" charset="0"/>
+                <a:cs typeface="Arial" panose="020B0604020202020204" pitchFamily="34" charset="0"/>
+              </a:defRPr>
             </a:lvl1pPr>
           </a:lstStyle>
           <a:p>
@@ -1113,12 +1116,90 @@
           </a:p>
         </p:txBody>
       </p:sp>
+      <p:sp>
+        <p:nvSpPr>
+          <p:cNvPr id="5" name="orgname">
+            <a:extLst>
+              <a:ext uri="{FF2B5EF4-FFF2-40B4-BE49-F238E27FC236}">
+                <a16:creationId xmlns:a16="http://schemas.microsoft.com/office/drawing/2014/main" id="{33A7C9B6-DBD7-2B61-DD27-B359459C6DBE}"/>
+              </a:ext>
+            </a:extLst>
+          </p:cNvPr>
+          <p:cNvSpPr>
+            <a:spLocks noGrp="1"/>
+          </p:cNvSpPr>
+          <p:nvPr>
+            <p:ph type="body" sz="quarter" idx="13"/>
+          </p:nvPr>
+        </p:nvSpPr>
+        <p:spPr>
+          <a:xfrm>
+            <a:off x="6149365" y="4924425"/>
+            <a:ext cx="5561012" cy="320040"/>
+          </a:xfrm>
+        </p:spPr>
+        <p:txBody>
+          <a:bodyPr tIns="0" bIns="0" anchor="ctr" anchorCtr="0"/>
+          <a:lstStyle>
+            <a:lvl1pPr>
+              <a:buNone/>
+              <a:defRPr>
+                <a:latin typeface="Arial" panose="020B0604020202020204" pitchFamily="34" charset="0"/>
+                <a:cs typeface="Arial" panose="020B0604020202020204" pitchFamily="34" charset="0"/>
+              </a:defRPr>
+            </a:lvl1pPr>
+          </a:lstStyle>
+          <a:p>
+            <a:pPr lvl="0"/>
+            <a:endParaRPr lang="en-US" dirty="0"/>
+          </a:p>
+        </p:txBody>
+      </p:sp>
+      <p:sp>
+        <p:nvSpPr>
+          <p:cNvPr id="7" name="month_year">
+            <a:extLst>
+              <a:ext uri="{FF2B5EF4-FFF2-40B4-BE49-F238E27FC236}">
+                <a16:creationId xmlns:a16="http://schemas.microsoft.com/office/drawing/2014/main" id="{6F5952BE-55A5-1C39-5E5E-035243667E75}"/>
+              </a:ext>
+            </a:extLst>
+          </p:cNvPr>
+          <p:cNvSpPr>
+            <a:spLocks noGrp="1"/>
+          </p:cNvSpPr>
+          <p:nvPr>
+            <p:ph type="body" sz="quarter" idx="14"/>
+          </p:nvPr>
+        </p:nvSpPr>
+        <p:spPr>
+          <a:xfrm>
+            <a:off x="6149365" y="5275070"/>
+            <a:ext cx="5561012" cy="320040"/>
+          </a:xfrm>
+        </p:spPr>
+        <p:txBody>
+          <a:bodyPr tIns="0" bIns="0" anchor="ctr" anchorCtr="0"/>
+          <a:lstStyle>
+            <a:lvl1pPr>
+              <a:buNone/>
+              <a:defRPr>
+                <a:latin typeface="Arial" panose="020B0604020202020204" pitchFamily="34" charset="0"/>
+                <a:cs typeface="Arial" panose="020B0604020202020204" pitchFamily="34" charset="0"/>
+              </a:defRPr>
+            </a:lvl1pPr>
+          </a:lstStyle>
+          <a:p>
+            <a:pPr lvl="0"/>
+            <a:endParaRPr lang="en-US" dirty="0"/>
+          </a:p>
+        </p:txBody>
+      </p:sp>
       <p:pic>
         <p:nvPicPr>
-          <p:cNvPr id="2" name="Picture 1">
-            <a:extLst>
-              <a:ext uri="{FF2B5EF4-FFF2-40B4-BE49-F238E27FC236}">
-                <a16:creationId xmlns:a16="http://schemas.microsoft.com/office/drawing/2014/main" id="{B5422D96-EB6F-9EE4-2D78-3043BC60F2C3}"/>
+          <p:cNvPr id="4" name="Picture 3">
+            <a:extLst>
+              <a:ext uri="{FF2B5EF4-FFF2-40B4-BE49-F238E27FC236}">
+                <a16:creationId xmlns:a16="http://schemas.microsoft.com/office/drawing/2014/main" id="{18081953-2D72-9015-BF3C-8DBEEC90855A}"/>
               </a:ext>
             </a:extLst>
           </p:cNvPr>
@@ -1128,99 +1209,21 @@
           <p:nvPr userDrawn="1"/>
         </p:nvPicPr>
         <p:blipFill>
-          <a:blip r:embed="rId2">
-            <a:extLst>
-              <a:ext uri="{28A0092B-C50C-407E-A947-70E740481C1C}">
-                <a14:useLocalDpi xmlns:a14="http://schemas.microsoft.com/office/drawing/2010/main"/>
-              </a:ext>
-            </a:extLst>
-          </a:blip>
+          <a:blip r:embed="rId2"/>
           <a:stretch>
             <a:fillRect/>
           </a:stretch>
         </p:blipFill>
         <p:spPr>
           <a:xfrm>
-            <a:off x="10703753" y="536878"/>
-            <a:ext cx="1018401" cy="590745"/>
+            <a:off x="10707170" y="519883"/>
+            <a:ext cx="1014984" cy="624734"/>
           </a:xfrm>
           <a:prstGeom prst="rect">
             <a:avLst/>
           </a:prstGeom>
         </p:spPr>
       </p:pic>
-      <p:sp>
-        <p:nvSpPr>
-          <p:cNvPr id="5" name="orgname">
-            <a:extLst>
-              <a:ext uri="{FF2B5EF4-FFF2-40B4-BE49-F238E27FC236}">
-                <a16:creationId xmlns:a16="http://schemas.microsoft.com/office/drawing/2014/main" id="{33A7C9B6-DBD7-2B61-DD27-B359459C6DBE}"/>
-              </a:ext>
-            </a:extLst>
-          </p:cNvPr>
-          <p:cNvSpPr>
-            <a:spLocks noGrp="1"/>
-          </p:cNvSpPr>
-          <p:nvPr>
-            <p:ph type="body" sz="quarter" idx="13"/>
-          </p:nvPr>
-        </p:nvSpPr>
-        <p:spPr>
-          <a:xfrm>
-            <a:off x="6149365" y="4924425"/>
-            <a:ext cx="5561012" cy="320040"/>
-          </a:xfrm>
-        </p:spPr>
-        <p:txBody>
-          <a:bodyPr tIns="0" bIns="0" anchor="ctr" anchorCtr="0"/>
-          <a:lstStyle>
-            <a:lvl1pPr>
-              <a:buNone/>
-              <a:defRPr/>
-            </a:lvl1pPr>
-          </a:lstStyle>
-          <a:p>
-            <a:pPr lvl="0"/>
-            <a:endParaRPr lang="en-US" dirty="0"/>
-          </a:p>
-        </p:txBody>
-      </p:sp>
-      <p:sp>
-        <p:nvSpPr>
-          <p:cNvPr id="7" name="month_year">
-            <a:extLst>
-              <a:ext uri="{FF2B5EF4-FFF2-40B4-BE49-F238E27FC236}">
-                <a16:creationId xmlns:a16="http://schemas.microsoft.com/office/drawing/2014/main" id="{6F5952BE-55A5-1C39-5E5E-035243667E75}"/>
-              </a:ext>
-            </a:extLst>
-          </p:cNvPr>
-          <p:cNvSpPr>
-            <a:spLocks noGrp="1"/>
-          </p:cNvSpPr>
-          <p:nvPr>
-            <p:ph type="body" sz="quarter" idx="14"/>
-          </p:nvPr>
-        </p:nvSpPr>
-        <p:spPr>
-          <a:xfrm>
-            <a:off x="6149365" y="5275070"/>
-            <a:ext cx="5561012" cy="320040"/>
-          </a:xfrm>
-        </p:spPr>
-        <p:txBody>
-          <a:bodyPr tIns="0" bIns="0" anchor="ctr" anchorCtr="0"/>
-          <a:lstStyle>
-            <a:lvl1pPr>
-              <a:buNone/>
-              <a:defRPr/>
-            </a:lvl1pPr>
-          </a:lstStyle>
-          <a:p>
-            <a:pPr lvl="0"/>
-            <a:endParaRPr lang="en-US" dirty="0"/>
-          </a:p>
-        </p:txBody>
-      </p:sp>
     </p:spTree>
     <p:extLst>
       <p:ext uri="{BB962C8B-B14F-4D97-AF65-F5344CB8AC3E}">
@@ -1287,7 +1290,8 @@
                 <a:solidFill>
                   <a:schemeClr val="tx1"/>
                 </a:solidFill>
-                <a:latin typeface="+mn-lt"/>
+                <a:latin typeface="Arial" panose="020B0604020202020204" pitchFamily="34" charset="0"/>
+                <a:cs typeface="Arial" panose="020B0604020202020204" pitchFamily="34" charset="0"/>
               </a:defRPr>
             </a:lvl1pPr>
             <a:lvl2pPr marL="457200" indent="0">
@@ -1376,7 +1380,8 @@
                 <a:solidFill>
                   <a:srgbClr val="254A5D"/>
                 </a:solidFill>
-                <a:latin typeface="+mj-lt"/>
+                <a:latin typeface="Arial" panose="020B0604020202020204" pitchFamily="34" charset="0"/>
+                <a:cs typeface="Arial" panose="020B0604020202020204" pitchFamily="34" charset="0"/>
               </a:defRPr>
             </a:lvl1pPr>
             <a:lvl2pPr marL="457200" indent="0">
@@ -1489,8 +1494,8 @@
         </p:nvSpPr>
         <p:spPr>
           <a:xfrm>
-            <a:off x="10705617" y="165288"/>
-            <a:ext cx="1068479" cy="252587"/>
+            <a:off x="10600268" y="177252"/>
+            <a:ext cx="1173829" cy="228600"/>
           </a:xfrm>
           <a:prstGeom prst="rect">
             <a:avLst/>
@@ -1604,7 +1609,8 @@
                     <a:lumMod val="50000"/>
                   </a:schemeClr>
                 </a:solidFill>
-                <a:latin typeface="Karla Light" panose="020B0004030503030003" pitchFamily="34" charset="77"/>
+                <a:latin typeface="Arial" panose="020B0604020202020204" pitchFamily="34" charset="0"/>
+                <a:cs typeface="Arial" panose="020B0604020202020204" pitchFamily="34" charset="0"/>
               </a:rPr>
               <a:t> CCS Fundraising</a:t>
             </a:r>
@@ -1625,7 +1631,7 @@
         </p:nvSpPr>
         <p:spPr>
           <a:xfrm>
-            <a:off x="11711368" y="187043"/>
+            <a:off x="11711368" y="185007"/>
             <a:ext cx="354057" cy="230832"/>
           </a:xfrm>
           <a:prstGeom prst="rect">
@@ -1645,7 +1651,8 @@
                 <a:solidFill>
                   <a:srgbClr val="757575"/>
                 </a:solidFill>
-                <a:latin typeface="Karla Medium" panose="020B0004030503030003" pitchFamily="34" charset="77"/>
+                <a:latin typeface="Arial" panose="020B0604020202020204" pitchFamily="34" charset="0"/>
+                <a:cs typeface="Arial" panose="020B0604020202020204" pitchFamily="34" charset="0"/>
               </a:rPr>
               <a:pPr algn="ctr"/>
               <a:t>‹#›</a:t>
@@ -1654,6 +1661,8 @@
               <a:solidFill>
                 <a:srgbClr val="757575"/>
               </a:solidFill>
+              <a:latin typeface="Arial" panose="020B0604020202020204" pitchFamily="34" charset="0"/>
+              <a:cs typeface="Arial" panose="020B0604020202020204" pitchFamily="34" charset="0"/>
             </a:endParaRPr>
           </a:p>
         </p:txBody>
@@ -1690,7 +1699,10 @@
           <a:lstStyle>
             <a:lvl1pPr marL="0" indent="0">
               <a:buNone/>
-              <a:defRPr/>
+              <a:defRPr>
+                <a:latin typeface="Arial" panose="020B0604020202020204" pitchFamily="34" charset="0"/>
+                <a:cs typeface="Arial" panose="020B0604020202020204" pitchFamily="34" charset="0"/>
+              </a:defRPr>
             </a:lvl1pPr>
           </a:lstStyle>
           <a:p>
@@ -1726,7 +1738,10 @@
           <a:lstStyle>
             <a:lvl1pPr marL="0" indent="0">
               <a:buNone/>
-              <a:defRPr/>
+              <a:defRPr>
+                <a:latin typeface="Arial" panose="020B0604020202020204" pitchFamily="34" charset="0"/>
+                <a:cs typeface="Arial" panose="020B0604020202020204" pitchFamily="34" charset="0"/>
+              </a:defRPr>
             </a:lvl1pPr>
           </a:lstStyle>
           <a:p>
@@ -1768,6 +1783,8 @@
                 <a:solidFill>
                   <a:srgbClr val="254A5D"/>
                 </a:solidFill>
+                <a:latin typeface="Arial" panose="020B0604020202020204" pitchFamily="34" charset="0"/>
+                <a:cs typeface="Arial" panose="020B0604020202020204" pitchFamily="34" charset="0"/>
               </a:defRPr>
             </a:lvl1pPr>
           </a:lstStyle>
@@ -1804,7 +1821,10 @@
           <a:lstStyle>
             <a:lvl1pPr marL="0" indent="0">
               <a:buNone/>
-              <a:defRPr/>
+              <a:defRPr>
+                <a:latin typeface="Arial" panose="020B0604020202020204" pitchFamily="34" charset="0"/>
+                <a:cs typeface="Arial" panose="020B0604020202020204" pitchFamily="34" charset="0"/>
+              </a:defRPr>
             </a:lvl1pPr>
           </a:lstStyle>
           <a:p>
@@ -1847,6 +1867,8 @@
                     <a:lumMod val="85000"/>
                   </a:schemeClr>
                 </a:solidFill>
+                <a:latin typeface="Arial" panose="020B0604020202020204" pitchFamily="34" charset="0"/>
+                <a:cs typeface="Arial" panose="020B0604020202020204" pitchFamily="34" charset="0"/>
               </a:defRPr>
             </a:lvl1pPr>
           </a:lstStyle>
@@ -2157,7 +2179,7 @@
           <a:p>
             <a:fld id="{35B24283-4C9C-384C-9A69-259DDC60D95C}" type="datetimeFigureOut">
               <a:rPr lang="en-US" smtClean="0"/>
-              <a:t>3/26/2026</a:t>
+              <a:t>6/15/2026</a:t>
             </a:fld>
             <a:endParaRPr lang="en-US"/>
           </a:p>
@@ -2432,7 +2454,7 @@
           <a:p>
             <a:fld id="{35B24283-4C9C-384C-9A69-259DDC60D95C}" type="datetimeFigureOut">
               <a:rPr lang="en-US" smtClean="0"/>
-              <a:t>3/26/2026</a:t>
+              <a:t>6/15/2026</a:t>
             </a:fld>
             <a:endParaRPr lang="en-US"/>
           </a:p>
@@ -2697,7 +2719,7 @@
           <a:p>
             <a:fld id="{35B24283-4C9C-384C-9A69-259DDC60D95C}" type="datetimeFigureOut">
               <a:rPr lang="en-US" smtClean="0"/>
-              <a:t>3/26/2026</a:t>
+              <a:t>6/15/2026</a:t>
             </a:fld>
             <a:endParaRPr lang="en-US"/>
           </a:p>
@@ -3109,7 +3131,7 @@
           <a:p>
             <a:fld id="{35B24283-4C9C-384C-9A69-259DDC60D95C}" type="datetimeFigureOut">
               <a:rPr lang="en-US" smtClean="0"/>
-              <a:t>3/26/2026</a:t>
+              <a:t>6/15/2026</a:t>
             </a:fld>
             <a:endParaRPr lang="en-US"/>
           </a:p>
@@ -3250,7 +3272,7 @@
           <a:p>
             <a:fld id="{35B24283-4C9C-384C-9A69-259DDC60D95C}" type="datetimeFigureOut">
               <a:rPr lang="en-US" smtClean="0"/>
-              <a:t>3/26/2026</a:t>
+              <a:t>6/15/2026</a:t>
             </a:fld>
             <a:endParaRPr lang="en-US"/>
           </a:p>
@@ -3363,7 +3385,7 @@
           <a:p>
             <a:fld id="{35B24283-4C9C-384C-9A69-259DDC60D95C}" type="datetimeFigureOut">
               <a:rPr lang="en-US" smtClean="0"/>
-              <a:t>3/26/2026</a:t>
+              <a:t>6/15/2026</a:t>
             </a:fld>
             <a:endParaRPr lang="en-US"/>
           </a:p>
@@ -3674,7 +3696,7 @@
           <a:p>
             <a:fld id="{35B24283-4C9C-384C-9A69-259DDC60D95C}" type="datetimeFigureOut">
               <a:rPr lang="en-US" smtClean="0"/>
-              <a:t>3/26/2026</a:t>
+              <a:t>6/15/2026</a:t>
             </a:fld>
             <a:endParaRPr lang="en-US"/>
           </a:p>
@@ -3965,7 +3987,7 @@
           <a:p>
             <a:fld id="{35B24283-4C9C-384C-9A69-259DDC60D95C}" type="datetimeFigureOut">
               <a:rPr lang="en-US" smtClean="0"/>
-              <a:t>3/26/2026</a:t>
+              <a:t>6/15/2026</a:t>
             </a:fld>
             <a:endParaRPr lang="en-US"/>
           </a:p>
@@ -4696,7 +4718,7 @@
             <a:fld id="{3F2082E8-73AE-0443-9211-048CA87033AA}" type="datetimeFigureOut">
               <a:rPr lang="en-US" smtClean="0"/>
               <a:pPr/>
-              <a:t>3/26/2026</a:t>
+              <a:t>6/15/2026</a:t>
             </a:fld>
             <a:endParaRPr lang="en-US"/>
           </a:p>
@@ -5485,7 +5507,7 @@
         <p:spPr>
           <a:xfrm>
             <a:off x="457200" y="1783080"/>
-            <a:ext cx="7452360" cy="4745736"/>
+            <a:ext cx="7562088" cy="4407408"/>
           </a:xfrm>
           <a:prstGeom prst="rect">
             <a:avLst/>

</xml_diff>